<commit_message>
docs: update README project roadmap and synchronize presentation files
</commit_message>
<xml_diff>
--- a/presentation.pptx
+++ b/presentation.pptx
@@ -15314,6 +15314,150 @@
           </a:prstGeom>
         </p:spPr>
       </p:pic>
+      <p:pic>
+        <p:nvPicPr>
+          <p:cNvPr id="136" name="Picture 135" descr="image.png"/>
+          <p:cNvPicPr>
+            <a:picLocks noChangeAspect="1"/>
+          </p:cNvPicPr>
+          <p:nvPr/>
+        </p:nvPicPr>
+        <p:blipFill>
+          <a:blip r:embed="rId4"/>
+          <a:stretch>
+            <a:fillRect/>
+          </a:stretch>
+        </p:blipFill>
+        <p:spPr>
+          <a:xfrm>
+            <a:off x="6858000" y="1005840"/>
+            <a:ext cx="4846320" cy="3877056"/>
+          </a:xfrm>
+          <a:prstGeom prst="rect">
+            <a:avLst/>
+          </a:prstGeom>
+        </p:spPr>
+      </p:pic>
+      <p:pic>
+        <p:nvPicPr>
+          <p:cNvPr id="137" name="Picture 136" descr="image.png"/>
+          <p:cNvPicPr>
+            <a:picLocks noChangeAspect="1"/>
+          </p:cNvPicPr>
+          <p:nvPr/>
+        </p:nvPicPr>
+        <p:blipFill>
+          <a:blip r:embed="rId4"/>
+          <a:stretch>
+            <a:fillRect/>
+          </a:stretch>
+        </p:blipFill>
+        <p:spPr>
+          <a:xfrm>
+            <a:off x="6858000" y="1005840"/>
+            <a:ext cx="4846320" cy="3877056"/>
+          </a:xfrm>
+          <a:prstGeom prst="rect">
+            <a:avLst/>
+          </a:prstGeom>
+        </p:spPr>
+      </p:pic>
+      <p:pic>
+        <p:nvPicPr>
+          <p:cNvPr id="138" name="Picture 137" descr="image.png"/>
+          <p:cNvPicPr>
+            <a:picLocks noChangeAspect="1"/>
+          </p:cNvPicPr>
+          <p:nvPr/>
+        </p:nvPicPr>
+        <p:blipFill>
+          <a:blip r:embed="rId4"/>
+          <a:stretch>
+            <a:fillRect/>
+          </a:stretch>
+        </p:blipFill>
+        <p:spPr>
+          <a:xfrm>
+            <a:off x="6858000" y="1005840"/>
+            <a:ext cx="4846320" cy="3877056"/>
+          </a:xfrm>
+          <a:prstGeom prst="rect">
+            <a:avLst/>
+          </a:prstGeom>
+        </p:spPr>
+      </p:pic>
+      <p:pic>
+        <p:nvPicPr>
+          <p:cNvPr id="139" name="Picture 138" descr="image.png"/>
+          <p:cNvPicPr>
+            <a:picLocks noChangeAspect="1"/>
+          </p:cNvPicPr>
+          <p:nvPr/>
+        </p:nvPicPr>
+        <p:blipFill>
+          <a:blip r:embed="rId4"/>
+          <a:stretch>
+            <a:fillRect/>
+          </a:stretch>
+        </p:blipFill>
+        <p:spPr>
+          <a:xfrm>
+            <a:off x="6858000" y="1005840"/>
+            <a:ext cx="4846320" cy="3877056"/>
+          </a:xfrm>
+          <a:prstGeom prst="rect">
+            <a:avLst/>
+          </a:prstGeom>
+        </p:spPr>
+      </p:pic>
+      <p:pic>
+        <p:nvPicPr>
+          <p:cNvPr id="140" name="Picture 139" descr="image.png"/>
+          <p:cNvPicPr>
+            <a:picLocks noChangeAspect="1"/>
+          </p:cNvPicPr>
+          <p:nvPr/>
+        </p:nvPicPr>
+        <p:blipFill>
+          <a:blip r:embed="rId4"/>
+          <a:stretch>
+            <a:fillRect/>
+          </a:stretch>
+        </p:blipFill>
+        <p:spPr>
+          <a:xfrm>
+            <a:off x="6858000" y="1005840"/>
+            <a:ext cx="4846320" cy="3877056"/>
+          </a:xfrm>
+          <a:prstGeom prst="rect">
+            <a:avLst/>
+          </a:prstGeom>
+        </p:spPr>
+      </p:pic>
+      <p:pic>
+        <p:nvPicPr>
+          <p:cNvPr id="141" name="Picture 140" descr="image.png"/>
+          <p:cNvPicPr>
+            <a:picLocks noChangeAspect="1"/>
+          </p:cNvPicPr>
+          <p:nvPr/>
+        </p:nvPicPr>
+        <p:blipFill>
+          <a:blip r:embed="rId4"/>
+          <a:stretch>
+            <a:fillRect/>
+          </a:stretch>
+        </p:blipFill>
+        <p:spPr>
+          <a:xfrm>
+            <a:off x="6858000" y="1005840"/>
+            <a:ext cx="4846320" cy="3877056"/>
+          </a:xfrm>
+          <a:prstGeom prst="rect">
+            <a:avLst/>
+          </a:prstGeom>
+        </p:spPr>
+      </p:pic>
     </p:spTree>
   </p:cSld>
   <p:clrMapOvr>
@@ -15530,15 +15674,6 @@
               <a:buFont typeface="Arial"/>
               <a:buNone/>
             </a:pPr>
-            <a:r>
-              <a:rPr sz="1300" b="1" i="0">
-                <a:solidFill>
-                  <a:srgbClr val="1B365D"/>
-                </a:solidFill>
-                <a:latin typeface="Calibri"/>
-              </a:rPr>
-              <a:t>Phase 1 Accomplishments (Weeks 1 - 9) [COMPLETED]</a:t>
-            </a:r>
             <a:endParaRPr sz="3200">
               <a:solidFill>
                 <a:schemeClr val="dk1"/>
@@ -15549,168 +15684,630 @@
               <a:sym typeface="Times New Roman"/>
             </a:endParaRPr>
           </a:p>
-          <a:p>
-            <a:pPr lvl="1">
-              <a:spcAft>
-                <a:spcPts val="300"/>
-              </a:spcAft>
-            </a:pPr>
-            <a:r>
-              <a:rPr sz="1100" b="0" i="0">
-                <a:solidFill>
-                  <a:srgbClr val="282828"/>
-                </a:solidFill>
-                <a:latin typeface="Calibri"/>
-              </a:rPr>
-              <a:t>Data Pipeline: Built robust legacy pickle parsing script and dataset generator for 8 defect classes.</a:t>
-            </a:r>
-          </a:p>
-          <a:p>
-            <a:pPr lvl="1">
-              <a:spcAft>
-                <a:spcPts val="300"/>
-              </a:spcAft>
-            </a:pPr>
-            <a:r>
-              <a:rPr sz="1100" b="0" i="0">
-                <a:solidFill>
-                  <a:srgbClr val="282828"/>
-                </a:solidFill>
-                <a:latin typeface="Calibri"/>
-              </a:rPr>
-              <a:t>Model Training: Fine-tuned MobileNetV3-Small achieving 98.02% overall test accuracy.</a:t>
-            </a:r>
-          </a:p>
-          <a:p>
-            <a:pPr lvl="1">
-              <a:spcAft>
-                <a:spcPts val="300"/>
-              </a:spcAft>
-            </a:pPr>
-            <a:r>
-              <a:rPr sz="1100" b="0" i="0">
-                <a:solidFill>
-                  <a:srgbClr val="282828"/>
-                </a:solidFill>
-                <a:latin typeface="Calibri"/>
-              </a:rPr>
-              <a:t>Model Export: Successfully exported PyTorch model to ONNX format (model.onnx).</a:t>
-            </a:r>
-          </a:p>
-          <a:p>
-            <a:pPr lvl="1">
-              <a:spcAft>
-                <a:spcPts val="300"/>
-              </a:spcAft>
-            </a:pPr>
-            <a:r>
-              <a:rPr sz="1100" b="0" i="0">
-                <a:solidFill>
-                  <a:srgbClr val="282828"/>
-                </a:solidFill>
-                <a:latin typeface="Calibri"/>
-              </a:rPr>
-              <a:t>Inference Engine: Built and validated standalone run_inference.py script.</a:t>
-            </a:r>
-          </a:p>
-          <a:p>
-            <a:pPr>
-              <a:spcAft>
-                <a:spcPts val="400"/>
-              </a:spcAft>
-            </a:pPr>
-            <a:r>
-              <a:rPr sz="1300" b="1" i="0">
-                <a:solidFill>
-                  <a:srgbClr val="1B365D"/>
-                </a:solidFill>
-                <a:latin typeface="Calibri"/>
-              </a:rPr>
-              <a:t>Phase 2 Future Roadmap (Weeks 10 - 12) [PLANNED]</a:t>
-            </a:r>
-          </a:p>
-          <a:p>
-            <a:pPr lvl="1">
-              <a:spcAft>
-                <a:spcPts val="300"/>
-              </a:spcAft>
-            </a:pPr>
-            <a:r>
-              <a:rPr sz="1100" b="0" i="0">
-                <a:solidFill>
-                  <a:srgbClr val="282828"/>
-                </a:solidFill>
-                <a:latin typeface="Calibri"/>
-              </a:rPr>
-              <a:t>Edge Quantization: Apply INT8 / FP16 dynamic quantization for 4x memory reduction.</a:t>
-            </a:r>
-          </a:p>
-          <a:p>
-            <a:pPr lvl="1">
-              <a:spcAft>
-                <a:spcPts val="300"/>
-              </a:spcAft>
-            </a:pPr>
-            <a:r>
-              <a:rPr sz="1100" b="0" i="0">
-                <a:solidFill>
-                  <a:srgbClr val="282828"/>
-                </a:solidFill>
-                <a:latin typeface="Calibri"/>
-              </a:rPr>
-              <a:t>Hardware Benchmarking: Test ONNX Runtime latency on embedded edge hardware (NVIDIA Jetson / Raspberry Pi).</a:t>
-            </a:r>
-          </a:p>
-          <a:p>
-            <a:pPr lvl="1">
-              <a:spcAft>
-                <a:spcPts val="300"/>
-              </a:spcAft>
-            </a:pPr>
-            <a:r>
-              <a:rPr sz="1100" b="0" i="0">
-                <a:solidFill>
-                  <a:srgbClr val="282828"/>
-                </a:solidFill>
-                <a:latin typeface="Calibri"/>
-              </a:rPr>
-              <a:t>Web Dashboard Integration: Develop an interactive GUI for fab operators to upload wafer maps and visualize defect heatmaps.</a:t>
-            </a:r>
-          </a:p>
-          <a:p>
-            <a:pPr>
-              <a:spcAft>
-                <a:spcPts val="400"/>
-              </a:spcAft>
-            </a:pPr>
-            <a:r>
-              <a:rPr sz="1300" b="1" i="0">
-                <a:solidFill>
-                  <a:srgbClr val="1B365D"/>
-                </a:solidFill>
-                <a:latin typeface="Calibri"/>
-              </a:rPr>
-              <a:t>Key Deliverables &amp; Expected Impact</a:t>
-            </a:r>
-          </a:p>
-          <a:p>
-            <a:pPr lvl="1">
-              <a:spcAft>
-                <a:spcPts val="300"/>
-              </a:spcAft>
-            </a:pPr>
-            <a:r>
-              <a:rPr sz="1100" b="0" i="0">
-                <a:solidFill>
-                  <a:srgbClr val="282828"/>
-                </a:solidFill>
-                <a:latin typeface="Calibri"/>
-              </a:rPr>
-              <a:t>End-to-end automated Python pipeline, lightweight ONNX model (&lt;10MB), and &gt;98% accuracy on 121k test wafers.</a:t>
-            </a:r>
-          </a:p>
         </p:txBody>
       </p:sp>
+      <p:graphicFrame>
+        <p:nvGraphicFramePr>
+          <p:cNvPr id="143" name="Table 142"/>
+          <p:cNvGraphicFramePr>
+            <a:graphicFrameLocks noGrp="1"/>
+          </p:cNvGraphicFramePr>
+          <p:nvPr/>
+        </p:nvGraphicFramePr>
+        <p:xfrm>
+          <a:off x="457200" y="1005840"/>
+          <a:ext cx="11247120" cy="4754880"/>
+        </p:xfrm>
+        <a:graphic>
+          <a:graphicData uri="http://schemas.openxmlformats.org/drawingml/2006/table">
+            <a:tbl>
+              <a:tblPr firstRow="1" bandRow="1">
+                <a:tableStyleId>{5C22544A-7EE6-4342-B048-85BDC9FD1C3A}</a:tableStyleId>
+              </a:tblPr>
+              <a:tblGrid>
+                <a:gridCol w="1645920"/>
+                <a:gridCol w="5303520"/>
+                <a:gridCol w="4297680"/>
+              </a:tblGrid>
+              <a:tr h="950976">
+                <a:tc>
+                  <a:txBody>
+                    <a:bodyPr/>
+                    <a:lstStyle/>
+                    <a:p>
+                      <a:pPr algn="ctr"/>
+                      <a:r>
+                        <a:rPr sz="1300" b="1" i="0">
+                          <a:solidFill>
+                            <a:srgbClr val="FFFFFF"/>
+                          </a:solidFill>
+                          <a:latin typeface="Calibri"/>
+                        </a:rPr>
+                        <a:t>Weeks</a:t>
+                      </a:r>
+                    </a:p>
+                  </a:txBody>
+                  <a:tcPr>
+                    <a:solidFill>
+                      <a:srgbClr val="1B365D"/>
+                    </a:solidFill>
+                  </a:tcPr>
+                </a:tc>
+                <a:tc>
+                  <a:txBody>
+                    <a:bodyPr/>
+                    <a:lstStyle/>
+                    <a:p>
+                      <a:pPr algn="ctr"/>
+                      <a:r>
+                        <a:rPr sz="1300" b="1" i="0">
+                          <a:solidFill>
+                            <a:srgbClr val="FFFFFF"/>
+                          </a:solidFill>
+                          <a:latin typeface="Calibri"/>
+                        </a:rPr>
+                        <a:t>Tasks &amp; Technical Activities</a:t>
+                      </a:r>
+                    </a:p>
+                  </a:txBody>
+                  <a:tcPr>
+                    <a:solidFill>
+                      <a:srgbClr val="1B365D"/>
+                    </a:solidFill>
+                  </a:tcPr>
+                </a:tc>
+                <a:tc>
+                  <a:txBody>
+                    <a:bodyPr/>
+                    <a:lstStyle/>
+                    <a:p>
+                      <a:pPr algn="ctr"/>
+                      <a:r>
+                        <a:rPr sz="1300" b="1" i="0">
+                          <a:solidFill>
+                            <a:srgbClr val="FFFFFF"/>
+                          </a:solidFill>
+                          <a:latin typeface="Calibri"/>
+                        </a:rPr>
+                        <a:t>Key Deliverables &amp; Milestones</a:t>
+                      </a:r>
+                    </a:p>
+                  </a:txBody>
+                  <a:tcPr>
+                    <a:solidFill>
+                      <a:srgbClr val="1B365D"/>
+                    </a:solidFill>
+                  </a:tcPr>
+                </a:tc>
+              </a:tr>
+              <a:tr h="950976">
+                <a:tc>
+                  <a:txBody>
+                    <a:bodyPr/>
+                    <a:lstStyle/>
+                    <a:p>
+                      <a:pPr algn="ctr"/>
+                      <a:r>
+                        <a:rPr sz="1000" b="1" i="0">
+                          <a:solidFill>
+                            <a:srgbClr val="282828"/>
+                          </a:solidFill>
+                          <a:latin typeface="Calibri"/>
+                        </a:rPr>
+                        <a:t>Weeks 1 - 3</a:t>
+                      </a:r>
+                    </a:p>
+                  </a:txBody>
+                  <a:tcPr/>
+                </a:tc>
+                <a:tc>
+                  <a:txBody>
+                    <a:bodyPr/>
+                    <a:lstStyle/>
+                    <a:p>
+                      <a:pPr algn="l"/>
+                      <a:r>
+                        <a:rPr sz="1000" b="0" i="0">
+                          <a:solidFill>
+                            <a:srgbClr val="282828"/>
+                          </a:solidFill>
+                          <a:latin typeface="Calibri"/>
+                        </a:rPr>
+                        <a:t>Data Pipeline &amp; Preprocessing:</a:t>
+                      </a:r>
+                    </a:p>
+                    <a:p>
+                      <a:pPr algn="l"/>
+                      <a:r>
+                        <a:rPr sz="1000" b="0" i="0">
+                          <a:solidFill>
+                            <a:srgbClr val="282828"/>
+                          </a:solidFill>
+                          <a:latin typeface="Calibri"/>
+                        </a:rPr>
+                        <a:t>- Parse legacy LSWMD.pkl (811,472 records)</a:t>
+                      </a:r>
+                    </a:p>
+                    <a:p>
+                      <a:pPr algn="l"/>
+                      <a:r>
+                        <a:rPr sz="1000" b="0" i="0">
+                          <a:solidFill>
+                            <a:srgbClr val="282828"/>
+                          </a:solidFill>
+                          <a:latin typeface="Calibri"/>
+                        </a:rPr>
+                        <a:t>- Patch pandas index unpickling compatibility</a:t>
+                      </a:r>
+                    </a:p>
+                    <a:p>
+                      <a:pPr algn="l"/>
+                      <a:r>
+                        <a:rPr sz="1000" b="0" i="0">
+                          <a:solidFill>
+                            <a:srgbClr val="282828"/>
+                          </a:solidFill>
+                          <a:latin typeface="Calibri"/>
+                        </a:rPr>
+                        <a:t>- Resize wafer maps to 224x224 grayscale</a:t>
+                      </a:r>
+                    </a:p>
+                    <a:p>
+                      <a:pPr algn="l"/>
+                      <a:r>
+                        <a:rPr sz="1000" b="0" i="0">
+                          <a:solidFill>
+                            <a:srgbClr val="282828"/>
+                          </a:solidFill>
+                          <a:latin typeface="Calibri"/>
+                        </a:rPr>
+                        <a:t>- Stratified 70/15/15 train/val/test split</a:t>
+                      </a:r>
+                    </a:p>
+                  </a:txBody>
+                  <a:tcPr/>
+                </a:tc>
+                <a:tc>
+                  <a:txBody>
+                    <a:bodyPr/>
+                    <a:lstStyle/>
+                    <a:p>
+                      <a:pPr algn="l"/>
+                      <a:r>
+                        <a:rPr sz="1000" b="0" i="0">
+                          <a:solidFill>
+                            <a:srgbClr val="282828"/>
+                          </a:solidFill>
+                          <a:latin typeface="Calibri"/>
+                        </a:rPr>
+                        <a:t>- Custom pandas patch module</a:t>
+                      </a:r>
+                    </a:p>
+                    <a:p>
+                      <a:pPr algn="l"/>
+                      <a:r>
+                        <a:rPr sz="1000" b="0" i="0">
+                          <a:solidFill>
+                            <a:srgbClr val="282828"/>
+                          </a:solidFill>
+                          <a:latin typeface="Calibri"/>
+                        </a:rPr>
+                        <a:t>- Standardized dataset generator</a:t>
+                      </a:r>
+                    </a:p>
+                    <a:p>
+                      <a:pPr algn="l"/>
+                      <a:r>
+                        <a:rPr sz="1000" b="0" i="0">
+                          <a:solidFill>
+                            <a:srgbClr val="282828"/>
+                          </a:solidFill>
+                          <a:latin typeface="Calibri"/>
+                        </a:rPr>
+                        <a:t>- 8-class preprocessed image dataset (output/Dataset/)</a:t>
+                      </a:r>
+                    </a:p>
+                  </a:txBody>
+                  <a:tcPr/>
+                </a:tc>
+              </a:tr>
+              <a:tr h="950976">
+                <a:tc>
+                  <a:txBody>
+                    <a:bodyPr/>
+                    <a:lstStyle/>
+                    <a:p>
+                      <a:pPr algn="ctr"/>
+                      <a:r>
+                        <a:rPr sz="1000" b="1" i="0">
+                          <a:solidFill>
+                            <a:srgbClr val="282828"/>
+                          </a:solidFill>
+                          <a:latin typeface="Calibri"/>
+                        </a:rPr>
+                        <a:t>Weeks 4 - 6</a:t>
+                      </a:r>
+                    </a:p>
+                  </a:txBody>
+                  <a:tcPr/>
+                </a:tc>
+                <a:tc>
+                  <a:txBody>
+                    <a:bodyPr/>
+                    <a:lstStyle/>
+                    <a:p>
+                      <a:pPr algn="l"/>
+                      <a:r>
+                        <a:rPr sz="1000" b="0" i="0">
+                          <a:solidFill>
+                            <a:srgbClr val="282828"/>
+                          </a:solidFill>
+                          <a:latin typeface="Calibri"/>
+                        </a:rPr>
+                        <a:t>Model Training &amp; Tuning:</a:t>
+                      </a:r>
+                    </a:p>
+                    <a:p>
+                      <a:pPr algn="l"/>
+                      <a:r>
+                        <a:rPr sz="1000" b="0" i="0">
+                          <a:solidFill>
+                            <a:srgbClr val="282828"/>
+                          </a:solidFill>
+                          <a:latin typeface="Calibri"/>
+                        </a:rPr>
+                        <a:t>- Fine-tune MobileNetV3-Small in PyTorch</a:t>
+                      </a:r>
+                    </a:p>
+                    <a:p>
+                      <a:pPr algn="l"/>
+                      <a:r>
+                        <a:rPr sz="1000" b="0" i="0">
+                          <a:solidFill>
+                            <a:srgbClr val="282828"/>
+                          </a:solidFill>
+                          <a:latin typeface="Calibri"/>
+                        </a:rPr>
+                        <a:t>- Apply transfer learning with Adam (lr=3e-4)</a:t>
+                      </a:r>
+                    </a:p>
+                    <a:p>
+                      <a:pPr algn="l"/>
+                      <a:r>
+                        <a:rPr sz="1000" b="0" i="0">
+                          <a:solidFill>
+                            <a:srgbClr val="282828"/>
+                          </a:solidFill>
+                          <a:latin typeface="Calibri"/>
+                        </a:rPr>
+                        <a:t>- Execute 8 training epochs with Cross-Entropy loss</a:t>
+                      </a:r>
+                    </a:p>
+                    <a:p>
+                      <a:pPr algn="l"/>
+                      <a:r>
+                        <a:rPr sz="1000" b="0" i="0">
+                          <a:solidFill>
+                            <a:srgbClr val="282828"/>
+                          </a:solidFill>
+                          <a:latin typeface="Calibri"/>
+                        </a:rPr>
+                        <a:t>- Monitor validation loss and accuracy metrics</a:t>
+                      </a:r>
+                    </a:p>
+                  </a:txBody>
+                  <a:tcPr/>
+                </a:tc>
+                <a:tc>
+                  <a:txBody>
+                    <a:bodyPr/>
+                    <a:lstStyle/>
+                    <a:p>
+                      <a:pPr algn="l"/>
+                      <a:r>
+                        <a:rPr sz="1000" b="0" i="0">
+                          <a:solidFill>
+                            <a:srgbClr val="282828"/>
+                          </a:solidFill>
+                          <a:latin typeface="Calibri"/>
+                        </a:rPr>
+                        <a:t>- Trained PyTorch model weights (mobilenetv3_lswmd.pth)</a:t>
+                      </a:r>
+                    </a:p>
+                    <a:p>
+                      <a:pPr algn="l"/>
+                      <a:r>
+                        <a:rPr sz="1000" b="0" i="0">
+                          <a:solidFill>
+                            <a:srgbClr val="282828"/>
+                          </a:solidFill>
+                          <a:latin typeface="Calibri"/>
+                        </a:rPr>
+                        <a:t>- 98.02% overall test accuracy report</a:t>
+                      </a:r>
+                    </a:p>
+                    <a:p>
+                      <a:pPr algn="l"/>
+                      <a:r>
+                        <a:rPr sz="1000" b="0" i="0">
+                          <a:solidFill>
+                            <a:srgbClr val="282828"/>
+                          </a:solidFill>
+                          <a:latin typeface="Calibri"/>
+                        </a:rPr>
+                        <a:t>- Detailed training/validation log files</a:t>
+                      </a:r>
+                    </a:p>
+                  </a:txBody>
+                  <a:tcPr/>
+                </a:tc>
+              </a:tr>
+              <a:tr h="950976">
+                <a:tc>
+                  <a:txBody>
+                    <a:bodyPr/>
+                    <a:lstStyle/>
+                    <a:p>
+                      <a:pPr algn="ctr"/>
+                      <a:r>
+                        <a:rPr sz="1000" b="1" i="0">
+                          <a:solidFill>
+                            <a:srgbClr val="282828"/>
+                          </a:solidFill>
+                          <a:latin typeface="Calibri"/>
+                        </a:rPr>
+                        <a:t>Weeks 7 - 9</a:t>
+                      </a:r>
+                    </a:p>
+                  </a:txBody>
+                  <a:tcPr/>
+                </a:tc>
+                <a:tc>
+                  <a:txBody>
+                    <a:bodyPr/>
+                    <a:lstStyle/>
+                    <a:p>
+                      <a:pPr algn="l"/>
+                      <a:r>
+                        <a:rPr sz="1000" b="0" i="0">
+                          <a:solidFill>
+                            <a:srgbClr val="282828"/>
+                          </a:solidFill>
+                          <a:latin typeface="Calibri"/>
+                        </a:rPr>
+                        <a:t>Model Export &amp; Optimization:</a:t>
+                      </a:r>
+                    </a:p>
+                    <a:p>
+                      <a:pPr algn="l"/>
+                      <a:r>
+                        <a:rPr sz="1000" b="0" i="0">
+                          <a:solidFill>
+                            <a:srgbClr val="282828"/>
+                          </a:solidFill>
+                          <a:latin typeface="Calibri"/>
+                        </a:rPr>
+                        <a:t>- Convert PyTorch weights to open ONNX format</a:t>
+                      </a:r>
+                    </a:p>
+                    <a:p>
+                      <a:pPr algn="l"/>
+                      <a:r>
+                        <a:rPr sz="1000" b="0" i="0">
+                          <a:solidFill>
+                            <a:srgbClr val="282828"/>
+                          </a:solidFill>
+                          <a:latin typeface="Calibri"/>
+                        </a:rPr>
+                        <a:t>- Configure opset 12 with dynamic batch size axes</a:t>
+                      </a:r>
+                    </a:p>
+                    <a:p>
+                      <a:pPr algn="l"/>
+                      <a:r>
+                        <a:rPr sz="1000" b="0" i="0">
+                          <a:solidFill>
+                            <a:srgbClr val="282828"/>
+                          </a:solidFill>
+                          <a:latin typeface="Calibri"/>
+                        </a:rPr>
+                        <a:t>- Validate ONNX Runtime session execution</a:t>
+                      </a:r>
+                    </a:p>
+                    <a:p>
+                      <a:pPr algn="l"/>
+                      <a:r>
+                        <a:rPr sz="1000" b="0" i="0">
+                          <a:solidFill>
+                            <a:srgbClr val="282828"/>
+                          </a:solidFill>
+                          <a:latin typeface="Calibri"/>
+                        </a:rPr>
+                        <a:t>- Generate classification metrics &amp; plots</a:t>
+                      </a:r>
+                    </a:p>
+                  </a:txBody>
+                  <a:tcPr/>
+                </a:tc>
+                <a:tc>
+                  <a:txBody>
+                    <a:bodyPr/>
+                    <a:lstStyle/>
+                    <a:p>
+                      <a:pPr algn="l"/>
+                      <a:r>
+                        <a:rPr sz="1000" b="0" i="0">
+                          <a:solidFill>
+                            <a:srgbClr val="282828"/>
+                          </a:solidFill>
+                          <a:latin typeface="Calibri"/>
+                        </a:rPr>
+                        <a:t>- Optimized ONNX model file (model.onnx)</a:t>
+                      </a:r>
+                    </a:p>
+                    <a:p>
+                      <a:pPr algn="l"/>
+                      <a:r>
+                        <a:rPr sz="1000" b="0" i="0">
+                          <a:solidFill>
+                            <a:srgbClr val="282828"/>
+                          </a:solidFill>
+                          <a:latin typeface="Calibri"/>
+                        </a:rPr>
+                        <a:t>- Classification report &amp; metrics summary</a:t>
+                      </a:r>
+                    </a:p>
+                    <a:p>
+                      <a:pPr algn="l"/>
+                      <a:r>
+                        <a:rPr sz="1000" b="0" i="0">
+                          <a:solidFill>
+                            <a:srgbClr val="282828"/>
+                          </a:solidFill>
+                          <a:latin typeface="Calibri"/>
+                        </a:rPr>
+                        <a:t>- High-res confusion matrix heatmap plot</a:t>
+                      </a:r>
+                    </a:p>
+                  </a:txBody>
+                  <a:tcPr/>
+                </a:tc>
+              </a:tr>
+              <a:tr h="950976">
+                <a:tc>
+                  <a:txBody>
+                    <a:bodyPr/>
+                    <a:lstStyle/>
+                    <a:p>
+                      <a:pPr algn="ctr"/>
+                      <a:r>
+                        <a:rPr sz="1000" b="1" i="0">
+                          <a:solidFill>
+                            <a:srgbClr val="282828"/>
+                          </a:solidFill>
+                          <a:latin typeface="Calibri"/>
+                        </a:rPr>
+                        <a:t>Weeks 10 - 12</a:t>
+                      </a:r>
+                    </a:p>
+                  </a:txBody>
+                  <a:tcPr/>
+                </a:tc>
+                <a:tc>
+                  <a:txBody>
+                    <a:bodyPr/>
+                    <a:lstStyle/>
+                    <a:p>
+                      <a:pPr algn="l"/>
+                      <a:r>
+                        <a:rPr sz="1000" b="0" i="0">
+                          <a:solidFill>
+                            <a:srgbClr val="282828"/>
+                          </a:solidFill>
+                          <a:latin typeface="Calibri"/>
+                        </a:rPr>
+                        <a:t>Inference Engine &amp; CLI Validation:</a:t>
+                      </a:r>
+                    </a:p>
+                    <a:p>
+                      <a:pPr algn="l"/>
+                      <a:r>
+                        <a:rPr sz="1000" b="0" i="0">
+                          <a:solidFill>
+                            <a:srgbClr val="282828"/>
+                          </a:solidFill>
+                          <a:latin typeface="Calibri"/>
+                        </a:rPr>
+                        <a:t>- Develop standalone run_inference.py script</a:t>
+                      </a:r>
+                    </a:p>
+                    <a:p>
+                      <a:pPr algn="l"/>
+                      <a:r>
+                        <a:rPr sz="1000" b="0" i="0">
+                          <a:solidFill>
+                            <a:srgbClr val="282828"/>
+                          </a:solidFill>
+                          <a:latin typeface="Calibri"/>
+                        </a:rPr>
+                        <a:t>- Implement ImageNet tensor normalization</a:t>
+                      </a:r>
+                    </a:p>
+                    <a:p>
+                      <a:pPr algn="l"/>
+                      <a:r>
+                        <a:rPr sz="1000" b="0" i="0">
+                          <a:solidFill>
+                            <a:srgbClr val="282828"/>
+                          </a:solidFill>
+                          <a:latin typeface="Calibri"/>
+                        </a:rPr>
+                        <a:t>- Compute top-3 defect probability confidence scores</a:t>
+                      </a:r>
+                    </a:p>
+                    <a:p>
+                      <a:pPr algn="l"/>
+                      <a:r>
+                        <a:rPr sz="1000" b="0" i="0">
+                          <a:solidFill>
+                            <a:srgbClr val="282828"/>
+                          </a:solidFill>
+                          <a:latin typeface="Calibri"/>
+                        </a:rPr>
+                        <a:t>- Validate real-time single image CPU/edge inference</a:t>
+                      </a:r>
+                    </a:p>
+                  </a:txBody>
+                  <a:tcPr/>
+                </a:tc>
+                <a:tc>
+                  <a:txBody>
+                    <a:bodyPr/>
+                    <a:lstStyle/>
+                    <a:p>
+                      <a:pPr algn="l"/>
+                      <a:r>
+                        <a:rPr sz="1000" b="0" i="0">
+                          <a:solidFill>
+                            <a:srgbClr val="282828"/>
+                          </a:solidFill>
+                          <a:latin typeface="Calibri"/>
+                        </a:rPr>
+                        <a:t>- Standalone inference engine script (run_inference.py)</a:t>
+                      </a:r>
+                    </a:p>
+                    <a:p>
+                      <a:pPr algn="l"/>
+                      <a:r>
+                        <a:rPr sz="1000" b="0" i="0">
+                          <a:solidFill>
+                            <a:srgbClr val="282828"/>
+                          </a:solidFill>
+                          <a:latin typeface="Calibri"/>
+                        </a:rPr>
+                        <a:t>- Dependency-free ONNX Runtime CLI tool</a:t>
+                      </a:r>
+                    </a:p>
+                    <a:p>
+                      <a:pPr algn="l"/>
+                      <a:r>
+                        <a:rPr sz="1000" b="0" i="0">
+                          <a:solidFill>
+                            <a:srgbClr val="282828"/>
+                          </a:solidFill>
+                          <a:latin typeface="Calibri"/>
+                        </a:rPr>
+                        <a:t>- Verified end-to-end classification pipeline</a:t>
+                      </a:r>
+                    </a:p>
+                  </a:txBody>
+                  <a:tcPr/>
+                </a:tc>
+              </a:tr>
+            </a:tbl>
+          </a:graphicData>
+        </a:graphic>
+      </p:graphicFrame>
     </p:spTree>
   </p:cSld>
   <p:clrMapOvr>
@@ -15926,7 +16523,7 @@
                 <a:spcPts val="0"/>
               </a:spcBef>
               <a:spcAft>
-                <a:spcPts val="400"/>
+                <a:spcPts val="1000"/>
               </a:spcAft>
               <a:buClr>
                 <a:schemeClr val="dk1"/>
@@ -15936,13 +16533,49 @@
               <a:buNone/>
             </a:pPr>
             <a:r>
-              <a:rPr sz="1300" b="1" i="0">
+              <a:rPr sz="1100" b="1" i="0">
                 <a:solidFill>
                   <a:srgbClr val="1B365D"/>
                 </a:solidFill>
                 <a:latin typeface="Calibri"/>
               </a:rPr>
-              <a:t>[1] M. Saqlain, Q. Riaz, A. Shahzad et al.,</a:t>
+              <a:t>[1] </a:t>
+            </a:r>
+            <a:r>
+              <a:rPr sz="1100" b="0" i="0">
+                <a:solidFill>
+                  <a:srgbClr val="282828"/>
+                </a:solidFill>
+                <a:latin typeface="Calibri"/>
+              </a:rPr>
+              <a:t>M. Saqlain, Q. Riaz, A. Shahzad, and P. M. Lee, </a:t>
+            </a:r>
+            <a:r>
+              <a:rPr sz="1100" b="0" i="0">
+                <a:solidFill>
+                  <a:srgbClr val="282828"/>
+                </a:solidFill>
+                <a:latin typeface="Calibri"/>
+              </a:rPr>
+              <a:t>"A Voting Ensemble Classifier for Semiconductor Wafer Defect Pattern Identification," </a:t>
+            </a:r>
+            <a:r>
+              <a:rPr sz="1100" b="0" i="1">
+                <a:solidFill>
+                  <a:srgbClr val="1B365D"/>
+                </a:solidFill>
+                <a:latin typeface="Calibri"/>
+              </a:rPr>
+              <a:t>IEEE Access</a:t>
+            </a:r>
+            <a:r>
+              <a:rPr sz="1100" b="0" i="0">
+                <a:solidFill>
+                  <a:srgbClr val="282828"/>
+                </a:solidFill>
+                <a:latin typeface="Calibri"/>
+              </a:rPr>
+              <a:t>, vol. 7, pp. 100415-100427, Jul. 2019.</a:t>
             </a:r>
             <a:endParaRPr sz="2900">
               <a:solidFill>
@@ -15955,11 +16588,20 @@
             </a:endParaRPr>
           </a:p>
           <a:p>
-            <a:pPr lvl="1">
-              <a:spcAft>
-                <a:spcPts val="300"/>
+            <a:pPr algn="l">
+              <a:spcAft>
+                <a:spcPts val="1000"/>
               </a:spcAft>
             </a:pPr>
+            <a:r>
+              <a:rPr sz="1100" b="1" i="0">
+                <a:solidFill>
+                  <a:srgbClr val="1B365D"/>
+                </a:solidFill>
+                <a:latin typeface="Calibri"/>
+              </a:rPr>
+              <a:t>[2] </a:t>
+            </a:r>
             <a:r>
               <a:rPr sz="1100" b="0" i="0">
                 <a:solidFill>
@@ -15967,31 +16609,8 @@
                 </a:solidFill>
                 <a:latin typeface="Calibri"/>
               </a:rPr>
-              <a:t>"A Voting Ensemble Classifier for Semiconductor Wafer Defect Pattern Identification," in IEEE Access, vol. 7, pp. 100415-100427, 2019.</a:t>
+              <a:t>T. Nakazawa and D. Kulkarni, </a:t>
             </a:r>
-          </a:p>
-          <a:p>
-            <a:pPr>
-              <a:spcAft>
-                <a:spcPts val="400"/>
-              </a:spcAft>
-            </a:pPr>
-            <a:r>
-              <a:rPr sz="1300" b="1" i="0">
-                <a:solidFill>
-                  <a:srgbClr val="1B365D"/>
-                </a:solidFill>
-                <a:latin typeface="Calibri"/>
-              </a:rPr>
-              <a:t>[2] T. Nakazawa and D. Kulkarni,</a:t>
-            </a:r>
-          </a:p>
-          <a:p>
-            <a:pPr lvl="1">
-              <a:spcAft>
-                <a:spcPts val="300"/>
-              </a:spcAft>
-            </a:pPr>
             <a:r>
               <a:rPr sz="1100" b="0" i="0">
                 <a:solidFill>
@@ -15999,31 +16618,17 @@
                 </a:solidFill>
                 <a:latin typeface="Calibri"/>
               </a:rPr>
-              <a:t>"Wafer Map Defect Pattern Classification and Hierarchical Feature Extraction Using Convolutional Neural Networks," in IEEE Transactions on Semiconductor Manufacturing, vol. 31, no. 2, pp. 318-324, May 2018.</a:t>
+              <a:t>"Wafer Map Defect Pattern Classification and Hierarchical Feature Extraction Using Convolutional Neural Networks," </a:t>
             </a:r>
-          </a:p>
-          <a:p>
-            <a:pPr>
-              <a:spcAft>
-                <a:spcPts val="400"/>
-              </a:spcAft>
-            </a:pPr>
             <a:r>
-              <a:rPr sz="1300" b="1" i="0">
+              <a:rPr sz="1100" b="0" i="1">
                 <a:solidFill>
                   <a:srgbClr val="1B365D"/>
                 </a:solidFill>
                 <a:latin typeface="Calibri"/>
               </a:rPr>
-              <a:t>[3] A. Howard, M. Sandler, G. Chu et al.,</a:t>
+              <a:t>IEEE Transactions on Semiconductor Manufacturing</a:t>
             </a:r>
-          </a:p>
-          <a:p>
-            <a:pPr lvl="1">
-              <a:spcAft>
-                <a:spcPts val="300"/>
-              </a:spcAft>
-            </a:pPr>
             <a:r>
               <a:rPr sz="1100" b="0" i="0">
                 <a:solidFill>
@@ -16031,31 +16636,24 @@
                 </a:solidFill>
                 <a:latin typeface="Calibri"/>
               </a:rPr>
-              <a:t>"Searching for MobileNetV3," in IEEE/CVF International Conference on Computer Vision (ICCV), 2019, pp. 1314-1324.</a:t>
+              <a:t>, vol. 31, no. 2, pp. 318-324, May 2018.</a:t>
             </a:r>
           </a:p>
           <a:p>
-            <a:pPr>
-              <a:spcAft>
-                <a:spcPts val="400"/>
+            <a:pPr algn="l">
+              <a:spcAft>
+                <a:spcPts val="1000"/>
               </a:spcAft>
             </a:pPr>
             <a:r>
-              <a:rPr sz="1300" b="1" i="0">
+              <a:rPr sz="1100" b="1" i="0">
                 <a:solidFill>
                   <a:srgbClr val="1B365D"/>
                 </a:solidFill>
                 <a:latin typeface="Calibri"/>
               </a:rPr>
-              <a:t>[4] J. S. Im et al.,</a:t>
+              <a:t>[3] </a:t>
             </a:r>
-          </a:p>
-          <a:p>
-            <a:pPr lvl="1">
-              <a:spcAft>
-                <a:spcPts val="300"/>
-              </a:spcAft>
-            </a:pPr>
             <a:r>
               <a:rPr sz="1100" b="0" i="0">
                 <a:solidFill>
@@ -16063,7 +16661,86 @@
                 </a:solidFill>
                 <a:latin typeface="Calibri"/>
               </a:rPr>
-              <a:t>"Lightweight Deep Learning Architecture for Real-Time Wafer Defect Pattern Classification," in IEEE Transactions on Industrial Electronics, vol. 68, no. 9, pp. 8850-8859, 2021.</a:t>
+              <a:t>A. Howard, M. Sandler, G. Chu, L. C. Chen, B. Chen, M. Tan, W. Wang, Y. Yukun, R. Vasudevan, A. Le, and H. Adam, </a:t>
+            </a:r>
+            <a:r>
+              <a:rPr sz="1100" b="0" i="0">
+                <a:solidFill>
+                  <a:srgbClr val="282828"/>
+                </a:solidFill>
+                <a:latin typeface="Calibri"/>
+              </a:rPr>
+              <a:t>"Searching for MobileNetV3," in </a:t>
+            </a:r>
+            <a:r>
+              <a:rPr sz="1100" b="0" i="1">
+                <a:solidFill>
+                  <a:srgbClr val="1B365D"/>
+                </a:solidFill>
+                <a:latin typeface="Calibri"/>
+              </a:rPr>
+              <a:t>Proc. IEEE/CVF Int. Conf. Comput. Vis. (ICCV)</a:t>
+            </a:r>
+            <a:r>
+              <a:rPr sz="1100" b="0" i="0">
+                <a:solidFill>
+                  <a:srgbClr val="282828"/>
+                </a:solidFill>
+                <a:latin typeface="Calibri"/>
+              </a:rPr>
+              <a:t>, Seoul, South Korea, Oct. 2019, pp. 1314-1324.</a:t>
+            </a:r>
+          </a:p>
+          <a:p>
+            <a:pPr algn="l">
+              <a:spcAft>
+                <a:spcPts val="1000"/>
+              </a:spcAft>
+            </a:pPr>
+            <a:r>
+              <a:rPr sz="1100" b="1" i="0">
+                <a:solidFill>
+                  <a:srgbClr val="1B365D"/>
+                </a:solidFill>
+                <a:latin typeface="Calibri"/>
+              </a:rPr>
+              <a:t>[4] </a:t>
+            </a:r>
+            <a:r>
+              <a:rPr sz="1100" b="0" i="0">
+                <a:solidFill>
+                  <a:srgbClr val="282828"/>
+                </a:solidFill>
+                <a:latin typeface="Calibri"/>
+              </a:rPr>
+              <a:t>J. S. Im, J. H. Lee, and J. G. Park, </a:t>
+            </a:r>
+            <a:r>
+              <a:rPr sz="1100" b="0" i="0">
+                <a:solidFill>
+                  <a:srgbClr val="282828"/>
+                </a:solidFill>
+                <a:latin typeface="Calibri"/>
+              </a:rPr>
+              <a:t>"Lightweight Deep Learning Architecture for Real-Time Wafer Defect Pattern Classification," </a:t>
+            </a:r>
+            <a:r>
+              <a:rPr sz="1100" b="0" i="1">
+                <a:solidFill>
+                  <a:srgbClr val="1B365D"/>
+                </a:solidFill>
+                <a:latin typeface="Calibri"/>
+              </a:rPr>
+              <a:t>IEEE Transactions on Industrial Electronics</a:t>
+            </a:r>
+            <a:r>
+              <a:rPr sz="1100" b="0" i="0">
+                <a:solidFill>
+                  <a:srgbClr val="282828"/>
+                </a:solidFill>
+                <a:latin typeface="Calibri"/>
+              </a:rPr>
+              <a:t>, vol. 68, no. 9, pp. 8850-8859, Sep. 2021.</a:t>
             </a:r>
           </a:p>
         </p:txBody>

</xml_diff>

<commit_message>
docs: update presentation files and add direct HuggingFace dataset download link to README
</commit_message>
<xml_diff>
--- a/presentation.pptx
+++ b/presentation.pptx
@@ -15117,6 +15117,22 @@
                 </a:solidFill>
                 <a:latin typeface="Calibri"/>
               </a:rPr>
+              <a:t>Dataset Source: HuggingFace (lslattery/wafer-defect-detection).</a:t>
+            </a:r>
+          </a:p>
+          <a:p>
+            <a:pPr lvl="1">
+              <a:spcAft>
+                <a:spcPts val="300"/>
+              </a:spcAft>
+            </a:pPr>
+            <a:r>
+              <a:rPr sz="1100" b="0" i="0">
+                <a:solidFill>
+                  <a:srgbClr val="282828"/>
+                </a:solidFill>
+                <a:latin typeface="Calibri"/>
+              </a:rPr>
               <a:t>Parsing: WM-811K (811,472 wafer maps) parsed via custom pandas patch.</a:t>
             </a:r>
           </a:p>
@@ -15458,6 +15474,30 @@
           </a:prstGeom>
         </p:spPr>
       </p:pic>
+      <p:pic>
+        <p:nvPicPr>
+          <p:cNvPr id="142" name="Picture 141" descr="image.png"/>
+          <p:cNvPicPr>
+            <a:picLocks noChangeAspect="1"/>
+          </p:cNvPicPr>
+          <p:nvPr/>
+        </p:nvPicPr>
+        <p:blipFill>
+          <a:blip r:embed="rId4"/>
+          <a:stretch>
+            <a:fillRect/>
+          </a:stretch>
+        </p:blipFill>
+        <p:spPr>
+          <a:xfrm>
+            <a:off x="6858000" y="1005840"/>
+            <a:ext cx="4846320" cy="3877056"/>
+          </a:xfrm>
+          <a:prstGeom prst="rect">
+            <a:avLst/>
+          </a:prstGeom>
+        </p:spPr>
+      </p:pic>
     </p:spTree>
   </p:cSld>
   <p:clrMapOvr>
@@ -15826,6 +15866,18 @@
                           <a:latin typeface="Calibri"/>
                         </a:rPr>
                         <a:t>- Parse legacy LSWMD.pkl (811,472 records)</a:t>
+                      </a:r>
+                    </a:p>
+                    <a:p>
+                      <a:pPr algn="l"/>
+                      <a:r>
+                        <a:rPr sz="1000" b="0" i="0">
+                          <a:solidFill>
+                            <a:srgbClr val="282828"/>
+                          </a:solidFill>
+                          <a:latin typeface="Calibri"/>
+                        </a:rPr>
+                        <a:t>- Source: HuggingFace lslattery/wafer-defect-detection</a:t>
                       </a:r>
                     </a:p>
                     <a:p>

</xml_diff>